<commit_message>
Portada: logo de LUZ
Co-Authored-By: Claude Fable 5.1 <noreply@anthropic.com>
Claude-Session: https://claude.ai/code/session_01EKouxmRFgKH3eDMtbZXSxw
</commit_message>
<xml_diff>
--- a/docs/presentaciones/Agrandamiento_gingival_inducido_por_farmacos.pptx
+++ b/docs/presentaciones/Agrandamiento_gingival_inducido_por_farmacos.pptx
@@ -3278,15 +3278,38 @@
           <a:chExt cx="0" cy="0"/>
         </a:xfrm>
       </p:grpSpPr>
-      <p:sp>
-        <p:nvSpPr>
-          <p:cNvPr id="2" name="Text 0"/>
-          <p:cNvSpPr txBox="1"/>
-          <p:nvPr/>
-        </p:nvSpPr>
-        <p:spPr>
-          <a:xfrm>
-            <a:off x="822960" y="822960"/>
+      <p:pic>
+        <p:nvPicPr>
+          <p:cNvPr id="2" name="Image 0" descr="/tmp/claude-0/-home-user-sondeo-caiena/ef64ae7b-88f9-53ed-bf0b-68d0a9f6b61e/scratchpad/img/LogoLUZ.png">    </p:cNvPr>
+          <p:cNvPicPr>
+            <a:picLocks noChangeAspect="1"/>
+          </p:cNvPicPr>
+          <p:nvPr/>
+        </p:nvPicPr>
+        <p:blipFill>
+          <a:blip r:embed="rId1"/>
+          <a:srcRect l="0" r="0" t="0" b="0"/>
+          <a:stretch/>
+        </p:blipFill>
+        <p:spPr>
+          <a:xfrm>
+            <a:off x="822960" y="731520"/>
+            <a:ext cx="777240" cy="960120"/>
+          </a:xfrm>
+          <a:prstGeom prst="rect">
+            <a:avLst/>
+          </a:prstGeom>
+        </p:spPr>
+      </p:pic>
+      <p:sp>
+        <p:nvSpPr>
+          <p:cNvPr id="3" name="Text 0"/>
+          <p:cNvSpPr txBox="1"/>
+          <p:nvPr/>
+        </p:nvSpPr>
+        <p:spPr>
+          <a:xfrm>
+            <a:off x="1783080" y="914400"/>
             <a:ext cx="7315200" cy="274320"/>
           </a:xfrm>
           <a:prstGeom prst="rect">
@@ -3319,13 +3342,13 @@
       </p:sp>
       <p:sp>
         <p:nvSpPr>
-          <p:cNvPr id="3" name="Text 1"/>
-          <p:cNvSpPr txBox="1"/>
-          <p:nvPr/>
-        </p:nvSpPr>
-        <p:spPr>
-          <a:xfrm>
-            <a:off x="822960" y="1097280"/>
+          <p:cNvPr id="4" name="Text 1"/>
+          <p:cNvSpPr txBox="1"/>
+          <p:nvPr/>
+        </p:nvSpPr>
+        <p:spPr>
+          <a:xfrm>
+            <a:off x="1783080" y="1188720"/>
             <a:ext cx="7315200" cy="274320"/>
           </a:xfrm>
           <a:prstGeom prst="rect">
@@ -3358,7 +3381,7 @@
       </p:sp>
       <p:sp>
         <p:nvSpPr>
-          <p:cNvPr id="4" name="Text 2"/>
+          <p:cNvPr id="5" name="Text 2"/>
           <p:cNvSpPr txBox="1"/>
           <p:nvPr/>
         </p:nvSpPr>
@@ -3417,7 +3440,7 @@
       </p:sp>
       <p:sp>
         <p:nvSpPr>
-          <p:cNvPr id="5" name="Text 3"/>
+          <p:cNvPr id="6" name="Text 3"/>
           <p:cNvSpPr txBox="1"/>
           <p:nvPr/>
         </p:nvSpPr>
@@ -3459,7 +3482,7 @@
       </p:sp>
       <p:sp>
         <p:nvSpPr>
-          <p:cNvPr id="6" name="Shape 4"/>
+          <p:cNvPr id="7" name="Shape 4"/>
           <p:cNvSpPr/>
           <p:nvPr/>
         </p:nvSpPr>
@@ -3482,7 +3505,7 @@
       </p:sp>
       <p:sp>
         <p:nvSpPr>
-          <p:cNvPr id="7" name="Text 5"/>
+          <p:cNvPr id="8" name="Text 5"/>
           <p:cNvSpPr txBox="1"/>
           <p:nvPr/>
         </p:nvSpPr>
@@ -3521,7 +3544,7 @@
       </p:sp>
       <p:sp>
         <p:nvSpPr>
-          <p:cNvPr id="8" name="Text 6"/>
+          <p:cNvPr id="9" name="Text 6"/>
           <p:cNvSpPr txBox="1"/>
           <p:nvPr/>
         </p:nvSpPr>

</xml_diff>